<commit_message>
Update final synthesis with collaboration extension
</commit_message>
<xml_diff>
--- a/docs/study/11-final-package/openerp-final-synthesis.pptx
+++ b/docs/study/11-final-package/openerp-final-synthesis.pptx
@@ -19,6 +19,9 @@
     <p:sldId id="267" r:id="rId13"/>
     <p:sldId id="268" r:id="rId14"/>
     <p:sldId id="269" r:id="rId15"/>
+    <p:sldId id="270" r:id="rId16"/>
+    <p:sldId id="271" r:id="rId17"/>
+    <p:sldId id="272" r:id="rId18"/>
   </p:sldIdLst>
   <p:sldSz cx="12192000" cy="6858000" type="wide"/>
   <p:notesSz cx="6858000" cy="9144000"/>
@@ -317,6 +320,147 @@
 </file>
 
 <file path=ppt/slides/slide14.xml><?xml version="1.0" encoding="utf-8"?>
+<p:sld xmlns:a="http://schemas.openxmlformats.org/drawingml/2006/main" xmlns:r="http://schemas.openxmlformats.org/officeDocument/2006/relationships" xmlns:p="http://schemas.openxmlformats.org/presentationml/2006/main">
+  <p:cSld>
+    <p:spTree>
+      <p:nvGrpSpPr>
+        <p:cNvPr id="1" name=""/>
+        <p:cNvGrpSpPr/>
+        <p:nvPr/>
+      </p:nvGrpSpPr>
+      <p:grpSpPr>
+        <a:xfrm>
+          <a:off x="0" y="0"/>
+          <a:ext cx="0" cy="0"/>
+          <a:chOff x="0" y="0"/>
+          <a:chExt cx="0" cy="0"/>
+        </a:xfrm>
+      </p:grpSpPr>
+      <p:pic>
+        <p:nvPicPr>
+          <p:cNvPr id="2" name="slide.png"/>
+          <p:cNvPicPr/>
+          <p:nvPr/>
+        </p:nvPicPr>
+        <p:blipFill>
+          <a:blip r:embed="rId1"/>
+          <a:stretch>
+            <a:fillRect/>
+          </a:stretch>
+        </p:blipFill>
+        <p:spPr>
+          <a:xfrm>
+            <a:off x="0" y="0"/>
+            <a:ext cx="12192000" cy="6858000"/>
+          </a:xfrm>
+          <a:prstGeom prst="rect">
+            <a:avLst/>
+          </a:prstGeom>
+        </p:spPr>
+      </p:pic>
+    </p:spTree>
+  </p:cSld>
+  <p:clrMapOvr>
+    <a:masterClrMapping/>
+  </p:clrMapOvr>
+</p:sld>
+</file>
+
+<file path=ppt/slides/slide15.xml><?xml version="1.0" encoding="utf-8"?>
+<p:sld xmlns:a="http://schemas.openxmlformats.org/drawingml/2006/main" xmlns:r="http://schemas.openxmlformats.org/officeDocument/2006/relationships" xmlns:p="http://schemas.openxmlformats.org/presentationml/2006/main">
+  <p:cSld>
+    <p:spTree>
+      <p:nvGrpSpPr>
+        <p:cNvPr id="1" name=""/>
+        <p:cNvGrpSpPr/>
+        <p:nvPr/>
+      </p:nvGrpSpPr>
+      <p:grpSpPr>
+        <a:xfrm>
+          <a:off x="0" y="0"/>
+          <a:ext cx="0" cy="0"/>
+          <a:chOff x="0" y="0"/>
+          <a:chExt cx="0" cy="0"/>
+        </a:xfrm>
+      </p:grpSpPr>
+      <p:pic>
+        <p:nvPicPr>
+          <p:cNvPr id="2" name="slide.png"/>
+          <p:cNvPicPr/>
+          <p:nvPr/>
+        </p:nvPicPr>
+        <p:blipFill>
+          <a:blip r:embed="rId1"/>
+          <a:stretch>
+            <a:fillRect/>
+          </a:stretch>
+        </p:blipFill>
+        <p:spPr>
+          <a:xfrm>
+            <a:off x="0" y="0"/>
+            <a:ext cx="12192000" cy="6858000"/>
+          </a:xfrm>
+          <a:prstGeom prst="rect">
+            <a:avLst/>
+          </a:prstGeom>
+        </p:spPr>
+      </p:pic>
+    </p:spTree>
+  </p:cSld>
+  <p:clrMapOvr>
+    <a:masterClrMapping/>
+  </p:clrMapOvr>
+</p:sld>
+</file>
+
+<file path=ppt/slides/slide16.xml><?xml version="1.0" encoding="utf-8"?>
+<p:sld xmlns:a="http://schemas.openxmlformats.org/drawingml/2006/main" xmlns:r="http://schemas.openxmlformats.org/officeDocument/2006/relationships" xmlns:p="http://schemas.openxmlformats.org/presentationml/2006/main">
+  <p:cSld>
+    <p:spTree>
+      <p:nvGrpSpPr>
+        <p:cNvPr id="1" name=""/>
+        <p:cNvGrpSpPr/>
+        <p:nvPr/>
+      </p:nvGrpSpPr>
+      <p:grpSpPr>
+        <a:xfrm>
+          <a:off x="0" y="0"/>
+          <a:ext cx="0" cy="0"/>
+          <a:chOff x="0" y="0"/>
+          <a:chExt cx="0" cy="0"/>
+        </a:xfrm>
+      </p:grpSpPr>
+      <p:pic>
+        <p:nvPicPr>
+          <p:cNvPr id="2" name="slide.png"/>
+          <p:cNvPicPr/>
+          <p:nvPr/>
+        </p:nvPicPr>
+        <p:blipFill>
+          <a:blip r:embed="rId1"/>
+          <a:stretch>
+            <a:fillRect/>
+          </a:stretch>
+        </p:blipFill>
+        <p:spPr>
+          <a:xfrm>
+            <a:off x="0" y="0"/>
+            <a:ext cx="12192000" cy="6858000"/>
+          </a:xfrm>
+          <a:prstGeom prst="rect">
+            <a:avLst/>
+          </a:prstGeom>
+        </p:spPr>
+      </p:pic>
+    </p:spTree>
+  </p:cSld>
+  <p:clrMapOvr>
+    <a:masterClrMapping/>
+  </p:clrMapOvr>
+</p:sld>
+</file>
+
+<file path=ppt/slides/slide17.xml><?xml version="1.0" encoding="utf-8"?>
 <p:sld xmlns:a="http://schemas.openxmlformats.org/drawingml/2006/main" xmlns:r="http://schemas.openxmlformats.org/officeDocument/2006/relationships" xmlns:p="http://schemas.openxmlformats.org/presentationml/2006/main">
   <p:cSld>
     <p:spTree>

</xml_diff>

<commit_message>
Update final PPTX with agentic addendum
</commit_message>
<xml_diff>
--- a/docs/study/11-final-package/openerp-final-synthesis.pptx
+++ b/docs/study/11-final-package/openerp-final-synthesis.pptx
@@ -22,6 +22,13 @@
     <p:sldId id="270" r:id="rId16"/>
     <p:sldId id="271" r:id="rId17"/>
     <p:sldId id="272" r:id="rId18"/>
+    <p:sldId id="273" r:id="rId19"/>
+    <p:sldId id="274" r:id="rId20"/>
+    <p:sldId id="275" r:id="rId21"/>
+    <p:sldId id="276" r:id="rId22"/>
+    <p:sldId id="277" r:id="rId23"/>
+    <p:sldId id="278" r:id="rId24"/>
+    <p:sldId id="279" r:id="rId25"/>
   </p:sldIdLst>
   <p:sldSz cx="12192000" cy="6858000" type="wide"/>
   <p:notesSz cx="6858000" cy="9144000"/>
@@ -507,6 +514,90 @@
 </p:sld>
 </file>
 
+<file path=ppt/slides/slide18.xml><?xml version="1.0" encoding="utf-8"?>
+<p:sld xmlns:a="http://schemas.openxmlformats.org/drawingml/2006/main" xmlns:p="http://schemas.openxmlformats.org/presentationml/2006/main" xmlns:r="http://schemas.openxmlformats.org/officeDocument/2006/relationships">
+  <p:cSld>
+    <p:spTree>
+      <p:nvGrpSpPr>
+        <p:cNvPr id="1" name=""/>
+        <p:cNvGrpSpPr/>
+        <p:nvPr/>
+      </p:nvGrpSpPr>
+      <p:grpSpPr/>
+      <p:pic>
+        <p:nvPicPr>
+          <p:cNvPr id="2" name="Picture 1" descr="agentic_01.png"/>
+          <p:cNvPicPr>
+            <a:picLocks noChangeAspect="1"/>
+          </p:cNvPicPr>
+          <p:nvPr/>
+        </p:nvPicPr>
+        <p:blipFill>
+          <a:blip r:embed="rId2"/>
+          <a:stretch>
+            <a:fillRect/>
+          </a:stretch>
+        </p:blipFill>
+        <p:spPr>
+          <a:xfrm>
+            <a:off x="0" y="0"/>
+            <a:ext cx="12192000" cy="6858000"/>
+          </a:xfrm>
+          <a:prstGeom prst="rect">
+            <a:avLst/>
+          </a:prstGeom>
+        </p:spPr>
+      </p:pic>
+    </p:spTree>
+  </p:cSld>
+  <p:clrMapOvr>
+    <a:masterClrMapping/>
+  </p:clrMapOvr>
+</p:sld>
+</file>
+
+<file path=ppt/slides/slide19.xml><?xml version="1.0" encoding="utf-8"?>
+<p:sld xmlns:a="http://schemas.openxmlformats.org/drawingml/2006/main" xmlns:p="http://schemas.openxmlformats.org/presentationml/2006/main" xmlns:r="http://schemas.openxmlformats.org/officeDocument/2006/relationships">
+  <p:cSld>
+    <p:spTree>
+      <p:nvGrpSpPr>
+        <p:cNvPr id="1" name=""/>
+        <p:cNvGrpSpPr/>
+        <p:nvPr/>
+      </p:nvGrpSpPr>
+      <p:grpSpPr/>
+      <p:pic>
+        <p:nvPicPr>
+          <p:cNvPr id="2" name="Picture 1" descr="agentic_02.png"/>
+          <p:cNvPicPr>
+            <a:picLocks noChangeAspect="1"/>
+          </p:cNvPicPr>
+          <p:nvPr/>
+        </p:nvPicPr>
+        <p:blipFill>
+          <a:blip r:embed="rId2"/>
+          <a:stretch>
+            <a:fillRect/>
+          </a:stretch>
+        </p:blipFill>
+        <p:spPr>
+          <a:xfrm>
+            <a:off x="0" y="0"/>
+            <a:ext cx="12192000" cy="6858000"/>
+          </a:xfrm>
+          <a:prstGeom prst="rect">
+            <a:avLst/>
+          </a:prstGeom>
+        </p:spPr>
+      </p:pic>
+    </p:spTree>
+  </p:cSld>
+  <p:clrMapOvr>
+    <a:masterClrMapping/>
+  </p:clrMapOvr>
+</p:sld>
+</file>
+
 <file path=ppt/slides/slide2.xml><?xml version="1.0" encoding="utf-8"?>
 <p:sld xmlns:a="http://schemas.openxmlformats.org/drawingml/2006/main" xmlns:r="http://schemas.openxmlformats.org/officeDocument/2006/relationships" xmlns:p="http://schemas.openxmlformats.org/presentationml/2006/main">
   <p:cSld>
@@ -532,6 +623,216 @@
         </p:nvPicPr>
         <p:blipFill>
           <a:blip r:embed="rId1"/>
+          <a:stretch>
+            <a:fillRect/>
+          </a:stretch>
+        </p:blipFill>
+        <p:spPr>
+          <a:xfrm>
+            <a:off x="0" y="0"/>
+            <a:ext cx="12192000" cy="6858000"/>
+          </a:xfrm>
+          <a:prstGeom prst="rect">
+            <a:avLst/>
+          </a:prstGeom>
+        </p:spPr>
+      </p:pic>
+    </p:spTree>
+  </p:cSld>
+  <p:clrMapOvr>
+    <a:masterClrMapping/>
+  </p:clrMapOvr>
+</p:sld>
+</file>
+
+<file path=ppt/slides/slide20.xml><?xml version="1.0" encoding="utf-8"?>
+<p:sld xmlns:a="http://schemas.openxmlformats.org/drawingml/2006/main" xmlns:p="http://schemas.openxmlformats.org/presentationml/2006/main" xmlns:r="http://schemas.openxmlformats.org/officeDocument/2006/relationships">
+  <p:cSld>
+    <p:spTree>
+      <p:nvGrpSpPr>
+        <p:cNvPr id="1" name=""/>
+        <p:cNvGrpSpPr/>
+        <p:nvPr/>
+      </p:nvGrpSpPr>
+      <p:grpSpPr/>
+      <p:pic>
+        <p:nvPicPr>
+          <p:cNvPr id="2" name="Picture 1" descr="agentic_03.png"/>
+          <p:cNvPicPr>
+            <a:picLocks noChangeAspect="1"/>
+          </p:cNvPicPr>
+          <p:nvPr/>
+        </p:nvPicPr>
+        <p:blipFill>
+          <a:blip r:embed="rId2"/>
+          <a:stretch>
+            <a:fillRect/>
+          </a:stretch>
+        </p:blipFill>
+        <p:spPr>
+          <a:xfrm>
+            <a:off x="0" y="0"/>
+            <a:ext cx="12192000" cy="6858000"/>
+          </a:xfrm>
+          <a:prstGeom prst="rect">
+            <a:avLst/>
+          </a:prstGeom>
+        </p:spPr>
+      </p:pic>
+    </p:spTree>
+  </p:cSld>
+  <p:clrMapOvr>
+    <a:masterClrMapping/>
+  </p:clrMapOvr>
+</p:sld>
+</file>
+
+<file path=ppt/slides/slide21.xml><?xml version="1.0" encoding="utf-8"?>
+<p:sld xmlns:a="http://schemas.openxmlformats.org/drawingml/2006/main" xmlns:p="http://schemas.openxmlformats.org/presentationml/2006/main" xmlns:r="http://schemas.openxmlformats.org/officeDocument/2006/relationships">
+  <p:cSld>
+    <p:spTree>
+      <p:nvGrpSpPr>
+        <p:cNvPr id="1" name=""/>
+        <p:cNvGrpSpPr/>
+        <p:nvPr/>
+      </p:nvGrpSpPr>
+      <p:grpSpPr/>
+      <p:pic>
+        <p:nvPicPr>
+          <p:cNvPr id="2" name="Picture 1" descr="agentic_04.png"/>
+          <p:cNvPicPr>
+            <a:picLocks noChangeAspect="1"/>
+          </p:cNvPicPr>
+          <p:nvPr/>
+        </p:nvPicPr>
+        <p:blipFill>
+          <a:blip r:embed="rId2"/>
+          <a:stretch>
+            <a:fillRect/>
+          </a:stretch>
+        </p:blipFill>
+        <p:spPr>
+          <a:xfrm>
+            <a:off x="0" y="0"/>
+            <a:ext cx="12192000" cy="6858000"/>
+          </a:xfrm>
+          <a:prstGeom prst="rect">
+            <a:avLst/>
+          </a:prstGeom>
+        </p:spPr>
+      </p:pic>
+    </p:spTree>
+  </p:cSld>
+  <p:clrMapOvr>
+    <a:masterClrMapping/>
+  </p:clrMapOvr>
+</p:sld>
+</file>
+
+<file path=ppt/slides/slide22.xml><?xml version="1.0" encoding="utf-8"?>
+<p:sld xmlns:a="http://schemas.openxmlformats.org/drawingml/2006/main" xmlns:p="http://schemas.openxmlformats.org/presentationml/2006/main" xmlns:r="http://schemas.openxmlformats.org/officeDocument/2006/relationships">
+  <p:cSld>
+    <p:spTree>
+      <p:nvGrpSpPr>
+        <p:cNvPr id="1" name=""/>
+        <p:cNvGrpSpPr/>
+        <p:nvPr/>
+      </p:nvGrpSpPr>
+      <p:grpSpPr/>
+      <p:pic>
+        <p:nvPicPr>
+          <p:cNvPr id="2" name="Picture 1" descr="agentic_05.png"/>
+          <p:cNvPicPr>
+            <a:picLocks noChangeAspect="1"/>
+          </p:cNvPicPr>
+          <p:nvPr/>
+        </p:nvPicPr>
+        <p:blipFill>
+          <a:blip r:embed="rId2"/>
+          <a:stretch>
+            <a:fillRect/>
+          </a:stretch>
+        </p:blipFill>
+        <p:spPr>
+          <a:xfrm>
+            <a:off x="0" y="0"/>
+            <a:ext cx="12192000" cy="6858000"/>
+          </a:xfrm>
+          <a:prstGeom prst="rect">
+            <a:avLst/>
+          </a:prstGeom>
+        </p:spPr>
+      </p:pic>
+    </p:spTree>
+  </p:cSld>
+  <p:clrMapOvr>
+    <a:masterClrMapping/>
+  </p:clrMapOvr>
+</p:sld>
+</file>
+
+<file path=ppt/slides/slide23.xml><?xml version="1.0" encoding="utf-8"?>
+<p:sld xmlns:a="http://schemas.openxmlformats.org/drawingml/2006/main" xmlns:p="http://schemas.openxmlformats.org/presentationml/2006/main" xmlns:r="http://schemas.openxmlformats.org/officeDocument/2006/relationships">
+  <p:cSld>
+    <p:spTree>
+      <p:nvGrpSpPr>
+        <p:cNvPr id="1" name=""/>
+        <p:cNvGrpSpPr/>
+        <p:nvPr/>
+      </p:nvGrpSpPr>
+      <p:grpSpPr/>
+      <p:pic>
+        <p:nvPicPr>
+          <p:cNvPr id="2" name="Picture 1" descr="agentic_06.png"/>
+          <p:cNvPicPr>
+            <a:picLocks noChangeAspect="1"/>
+          </p:cNvPicPr>
+          <p:nvPr/>
+        </p:nvPicPr>
+        <p:blipFill>
+          <a:blip r:embed="rId2"/>
+          <a:stretch>
+            <a:fillRect/>
+          </a:stretch>
+        </p:blipFill>
+        <p:spPr>
+          <a:xfrm>
+            <a:off x="0" y="0"/>
+            <a:ext cx="12192000" cy="6858000"/>
+          </a:xfrm>
+          <a:prstGeom prst="rect">
+            <a:avLst/>
+          </a:prstGeom>
+        </p:spPr>
+      </p:pic>
+    </p:spTree>
+  </p:cSld>
+  <p:clrMapOvr>
+    <a:masterClrMapping/>
+  </p:clrMapOvr>
+</p:sld>
+</file>
+
+<file path=ppt/slides/slide24.xml><?xml version="1.0" encoding="utf-8"?>
+<p:sld xmlns:a="http://schemas.openxmlformats.org/drawingml/2006/main" xmlns:p="http://schemas.openxmlformats.org/presentationml/2006/main" xmlns:r="http://schemas.openxmlformats.org/officeDocument/2006/relationships">
+  <p:cSld>
+    <p:spTree>
+      <p:nvGrpSpPr>
+        <p:cNvPr id="1" name=""/>
+        <p:cNvGrpSpPr/>
+        <p:nvPr/>
+      </p:nvGrpSpPr>
+      <p:grpSpPr/>
+      <p:pic>
+        <p:nvPicPr>
+          <p:cNvPr id="2" name="Picture 1" descr="agentic_07.png"/>
+          <p:cNvPicPr>
+            <a:picLocks noChangeAspect="1"/>
+          </p:cNvPicPr>
+          <p:nvPr/>
+        </p:nvPicPr>
+        <p:blipFill>
+          <a:blip r:embed="rId2"/>
           <a:stretch>
             <a:fillRect/>
           </a:stretch>

</xml_diff>